<commit_message>
EDA new files upload
</commit_message>
<xml_diff>
--- a/Statistics.pptx
+++ b/Statistics.pptx
@@ -8,11 +8,10 @@
     <p:sldId id="256" r:id="rId2"/>
     <p:sldId id="259" r:id="rId3"/>
     <p:sldId id="260" r:id="rId4"/>
-    <p:sldId id="263" r:id="rId5"/>
-    <p:sldId id="261" r:id="rId6"/>
-    <p:sldId id="262" r:id="rId7"/>
-    <p:sldId id="257" r:id="rId8"/>
-    <p:sldId id="258" r:id="rId9"/>
+    <p:sldId id="261" r:id="rId5"/>
+    <p:sldId id="262" r:id="rId6"/>
+    <p:sldId id="257" r:id="rId7"/>
+    <p:sldId id="258" r:id="rId8"/>
   </p:sldIdLst>
   <p:sldSz cx="12192000" cy="6858000"/>
   <p:notesSz cx="6858000" cy="9144000"/>
@@ -3171,7 +3170,7 @@
           <a:p>
             <a:fld id="{4F1FEE51-EDCB-4BA1-B2B1-7D94AB1EBB26}" type="datetimeFigureOut">
               <a:rPr lang="en-GB" smtClean="0"/>
-              <a:t>28/04/2025</a:t>
+              <a:t>29/04/2025</a:t>
             </a:fld>
             <a:endParaRPr lang="en-GB"/>
           </a:p>
@@ -3341,7 +3340,7 @@
           <a:p>
             <a:fld id="{4F1FEE51-EDCB-4BA1-B2B1-7D94AB1EBB26}" type="datetimeFigureOut">
               <a:rPr lang="en-GB" smtClean="0"/>
-              <a:t>28/04/2025</a:t>
+              <a:t>29/04/2025</a:t>
             </a:fld>
             <a:endParaRPr lang="en-GB"/>
           </a:p>
@@ -3521,7 +3520,7 @@
           <a:p>
             <a:fld id="{4F1FEE51-EDCB-4BA1-B2B1-7D94AB1EBB26}" type="datetimeFigureOut">
               <a:rPr lang="en-GB" smtClean="0"/>
-              <a:t>28/04/2025</a:t>
+              <a:t>29/04/2025</a:t>
             </a:fld>
             <a:endParaRPr lang="en-GB"/>
           </a:p>
@@ -3691,7 +3690,7 @@
           <a:p>
             <a:fld id="{4F1FEE51-EDCB-4BA1-B2B1-7D94AB1EBB26}" type="datetimeFigureOut">
               <a:rPr lang="en-GB" smtClean="0"/>
-              <a:t>28/04/2025</a:t>
+              <a:t>29/04/2025</a:t>
             </a:fld>
             <a:endParaRPr lang="en-GB"/>
           </a:p>
@@ -3937,7 +3936,7 @@
           <a:p>
             <a:fld id="{4F1FEE51-EDCB-4BA1-B2B1-7D94AB1EBB26}" type="datetimeFigureOut">
               <a:rPr lang="en-GB" smtClean="0"/>
-              <a:t>28/04/2025</a:t>
+              <a:t>29/04/2025</a:t>
             </a:fld>
             <a:endParaRPr lang="en-GB"/>
           </a:p>
@@ -4169,7 +4168,7 @@
           <a:p>
             <a:fld id="{4F1FEE51-EDCB-4BA1-B2B1-7D94AB1EBB26}" type="datetimeFigureOut">
               <a:rPr lang="en-GB" smtClean="0"/>
-              <a:t>28/04/2025</a:t>
+              <a:t>29/04/2025</a:t>
             </a:fld>
             <a:endParaRPr lang="en-GB"/>
           </a:p>
@@ -4536,7 +4535,7 @@
           <a:p>
             <a:fld id="{4F1FEE51-EDCB-4BA1-B2B1-7D94AB1EBB26}" type="datetimeFigureOut">
               <a:rPr lang="en-GB" smtClean="0"/>
-              <a:t>28/04/2025</a:t>
+              <a:t>29/04/2025</a:t>
             </a:fld>
             <a:endParaRPr lang="en-GB"/>
           </a:p>
@@ -4654,7 +4653,7 @@
           <a:p>
             <a:fld id="{4F1FEE51-EDCB-4BA1-B2B1-7D94AB1EBB26}" type="datetimeFigureOut">
               <a:rPr lang="en-GB" smtClean="0"/>
-              <a:t>28/04/2025</a:t>
+              <a:t>29/04/2025</a:t>
             </a:fld>
             <a:endParaRPr lang="en-GB"/>
           </a:p>
@@ -4749,7 +4748,7 @@
           <a:p>
             <a:fld id="{4F1FEE51-EDCB-4BA1-B2B1-7D94AB1EBB26}" type="datetimeFigureOut">
               <a:rPr lang="en-GB" smtClean="0"/>
-              <a:t>28/04/2025</a:t>
+              <a:t>29/04/2025</a:t>
             </a:fld>
             <a:endParaRPr lang="en-GB"/>
           </a:p>
@@ -5026,7 +5025,7 @@
           <a:p>
             <a:fld id="{4F1FEE51-EDCB-4BA1-B2B1-7D94AB1EBB26}" type="datetimeFigureOut">
               <a:rPr lang="en-GB" smtClean="0"/>
-              <a:t>28/04/2025</a:t>
+              <a:t>29/04/2025</a:t>
             </a:fld>
             <a:endParaRPr lang="en-GB"/>
           </a:p>
@@ -5283,7 +5282,7 @@
           <a:p>
             <a:fld id="{4F1FEE51-EDCB-4BA1-B2B1-7D94AB1EBB26}" type="datetimeFigureOut">
               <a:rPr lang="en-GB" smtClean="0"/>
-              <a:t>28/04/2025</a:t>
+              <a:t>29/04/2025</a:t>
             </a:fld>
             <a:endParaRPr lang="en-GB"/>
           </a:p>
@@ -5496,7 +5495,7 @@
           <a:p>
             <a:fld id="{4F1FEE51-EDCB-4BA1-B2B1-7D94AB1EBB26}" type="datetimeFigureOut">
               <a:rPr lang="en-GB" smtClean="0"/>
-              <a:t>28/04/2025</a:t>
+              <a:t>29/04/2025</a:t>
             </a:fld>
             <a:endParaRPr lang="en-GB"/>
           </a:p>
@@ -9625,755 +9624,6 @@
         <p:cNvPr id="1" name="">
           <a:extLst>
             <a:ext uri="{FF2B5EF4-FFF2-40B4-BE49-F238E27FC236}">
-              <a16:creationId xmlns:a16="http://schemas.microsoft.com/office/drawing/2014/main" id="{FBEF6E7D-A172-23C9-A965-9FAC80F56785}"/>
-            </a:ext>
-          </a:extLst>
-        </p:cNvPr>
-        <p:cNvGrpSpPr/>
-        <p:nvPr/>
-      </p:nvGrpSpPr>
-      <p:grpSpPr>
-        <a:xfrm>
-          <a:off x="0" y="0"/>
-          <a:ext cx="0" cy="0"/>
-          <a:chOff x="0" y="0"/>
-          <a:chExt cx="0" cy="0"/>
-        </a:xfrm>
-      </p:grpSpPr>
-      <p:sp useBgFill="1">
-        <p:nvSpPr>
-          <p:cNvPr id="18" name="Rectangle 17">
-            <a:extLst>
-              <a:ext uri="{FF2B5EF4-FFF2-40B4-BE49-F238E27FC236}">
-                <a16:creationId xmlns:a16="http://schemas.microsoft.com/office/drawing/2014/main" id="{1CC2553D-D047-3287-544C-0D15251073F6}"/>
-              </a:ext>
-              <a:ext uri="{C183D7F6-B498-43B3-948B-1728B52AA6E4}">
-                <adec:decorative xmlns:adec="http://schemas.microsoft.com/office/drawing/2017/decorative" val="1"/>
-              </a:ext>
-            </a:extLst>
-          </p:cNvPr>
-          <p:cNvSpPr>
-            <a:spLocks noGrp="1" noRot="1" noChangeAspect="1" noMove="1" noResize="1" noEditPoints="1" noAdjustHandles="1" noChangeArrowheads="1" noChangeShapeType="1" noTextEdit="1"/>
-          </p:cNvSpPr>
-          <p:nvPr>
-            <p:extLst>
-              <p:ext uri="{386F3935-93C4-4BCD-93E2-E3B085C9AB24}">
-                <p16:designElem xmlns:p16="http://schemas.microsoft.com/office/powerpoint/2015/main" val="1"/>
-              </p:ext>
-            </p:extLst>
-          </p:nvPr>
-        </p:nvSpPr>
-        <p:spPr>
-          <a:xfrm>
-            <a:off x="0" y="0"/>
-            <a:ext cx="12191999" cy="6857365"/>
-          </a:xfrm>
-          <a:prstGeom prst="rect">
-            <a:avLst/>
-          </a:prstGeom>
-          <a:ln>
-            <a:noFill/>
-          </a:ln>
-        </p:spPr>
-        <p:style>
-          <a:lnRef idx="2">
-            <a:schemeClr val="accent1">
-              <a:shade val="50000"/>
-            </a:schemeClr>
-          </a:lnRef>
-          <a:fillRef idx="1">
-            <a:schemeClr val="accent1"/>
-          </a:fillRef>
-          <a:effectRef idx="0">
-            <a:schemeClr val="accent1"/>
-          </a:effectRef>
-          <a:fontRef idx="minor">
-            <a:schemeClr val="lt1"/>
-          </a:fontRef>
-        </p:style>
-        <p:txBody>
-          <a:bodyPr rtlCol="0" anchor="ctr"/>
-          <a:lstStyle/>
-          <a:p>
-            <a:pPr algn="ctr"/>
-            <a:endParaRPr lang="en-US"/>
-          </a:p>
-        </p:txBody>
-      </p:sp>
-      <p:grpSp>
-        <p:nvGrpSpPr>
-          <p:cNvPr id="19" name="Group 18">
-            <a:extLst>
-              <a:ext uri="{FF2B5EF4-FFF2-40B4-BE49-F238E27FC236}">
-                <a16:creationId xmlns:a16="http://schemas.microsoft.com/office/drawing/2014/main" id="{2514D9C3-D52F-2BC7-924F-A63A5E13E7AB}"/>
-              </a:ext>
-              <a:ext uri="{C183D7F6-B498-43B3-948B-1728B52AA6E4}">
-                <adec:decorative xmlns:adec="http://schemas.microsoft.com/office/drawing/2017/decorative" val="1"/>
-              </a:ext>
-            </a:extLst>
-          </p:cNvPr>
-          <p:cNvGrpSpPr>
-            <a:grpSpLocks noGrp="1" noUngrp="1" noRot="1" noChangeAspect="1" noMove="1" noResize="1"/>
-          </p:cNvGrpSpPr>
-          <p:nvPr>
-            <p:extLst>
-              <p:ext uri="{386F3935-93C4-4BCD-93E2-E3B085C9AB24}">
-                <p16:designElem xmlns:p16="http://schemas.microsoft.com/office/powerpoint/2015/main" val="1"/>
-              </p:ext>
-            </p:extLst>
-          </p:nvPr>
-        </p:nvGrpSpPr>
-        <p:grpSpPr>
-          <a:xfrm>
-            <a:off x="4" y="1216597"/>
-            <a:ext cx="731521" cy="673460"/>
-            <a:chOff x="3940602" y="308034"/>
-            <a:chExt cx="2116791" cy="3428999"/>
-          </a:xfrm>
-          <a:solidFill>
-            <a:schemeClr val="accent4"/>
-          </a:solidFill>
-        </p:grpSpPr>
-        <p:sp>
-          <p:nvSpPr>
-            <p:cNvPr id="20" name="Rectangle 19">
-              <a:extLst>
-                <a:ext uri="{FF2B5EF4-FFF2-40B4-BE49-F238E27FC236}">
-                  <a16:creationId xmlns:a16="http://schemas.microsoft.com/office/drawing/2014/main" id="{53EADCEE-5728-03C6-C2CB-909E3E45A971}"/>
-                </a:ext>
-                <a:ext uri="{C183D7F6-B498-43B3-948B-1728B52AA6E4}">
-                  <adec:decorative xmlns:adec="http://schemas.microsoft.com/office/drawing/2017/decorative" val="1"/>
-                </a:ext>
-              </a:extLst>
-            </p:cNvPr>
-            <p:cNvSpPr/>
-            <p:nvPr>
-              <p:extLst>
-                <p:ext uri="{386F3935-93C4-4BCD-93E2-E3B085C9AB24}">
-                  <p16:designElem xmlns:p16="http://schemas.microsoft.com/office/powerpoint/2015/main" val="1"/>
-                </p:ext>
-              </p:extLst>
-            </p:nvPr>
-          </p:nvSpPr>
-          <p:spPr>
-            <a:xfrm>
-              <a:off x="3940602" y="308034"/>
-              <a:ext cx="566743" cy="3428999"/>
-            </a:xfrm>
-            <a:prstGeom prst="rect">
-              <a:avLst/>
-            </a:prstGeom>
-            <a:grpFill/>
-            <a:ln>
-              <a:noFill/>
-            </a:ln>
-          </p:spPr>
-          <p:style>
-            <a:lnRef idx="2">
-              <a:schemeClr val="accent1">
-                <a:shade val="50000"/>
-              </a:schemeClr>
-            </a:lnRef>
-            <a:fillRef idx="1">
-              <a:schemeClr val="accent1"/>
-            </a:fillRef>
-            <a:effectRef idx="0">
-              <a:schemeClr val="accent1"/>
-            </a:effectRef>
-            <a:fontRef idx="minor">
-              <a:schemeClr val="lt1"/>
-            </a:fontRef>
-          </p:style>
-          <p:txBody>
-            <a:bodyPr rtlCol="0" anchor="ctr"/>
-            <a:lstStyle/>
-            <a:p>
-              <a:pPr algn="ctr"/>
-              <a:endParaRPr lang="en-US"/>
-            </a:p>
-          </p:txBody>
-        </p:sp>
-        <p:sp>
-          <p:nvSpPr>
-            <p:cNvPr id="12" name="Rectangle 11">
-              <a:extLst>
-                <a:ext uri="{FF2B5EF4-FFF2-40B4-BE49-F238E27FC236}">
-                  <a16:creationId xmlns:a16="http://schemas.microsoft.com/office/drawing/2014/main" id="{4896DD8A-0B2D-5577-8BE1-E9ED91735E04}"/>
-                </a:ext>
-                <a:ext uri="{C183D7F6-B498-43B3-948B-1728B52AA6E4}">
-                  <adec:decorative xmlns:adec="http://schemas.microsoft.com/office/drawing/2017/decorative" val="1"/>
-                </a:ext>
-              </a:extLst>
-            </p:cNvPr>
-            <p:cNvSpPr/>
-            <p:nvPr>
-              <p:extLst>
-                <p:ext uri="{386F3935-93C4-4BCD-93E2-E3B085C9AB24}">
-                  <p16:designElem xmlns:p16="http://schemas.microsoft.com/office/powerpoint/2015/main" val="1"/>
-                </p:ext>
-              </p:extLst>
-            </p:nvPr>
-          </p:nvSpPr>
-          <p:spPr>
-            <a:xfrm>
-              <a:off x="4715626" y="308034"/>
-              <a:ext cx="566743" cy="3428999"/>
-            </a:xfrm>
-            <a:prstGeom prst="rect">
-              <a:avLst/>
-            </a:prstGeom>
-            <a:grpFill/>
-            <a:ln>
-              <a:noFill/>
-            </a:ln>
-          </p:spPr>
-          <p:style>
-            <a:lnRef idx="2">
-              <a:schemeClr val="accent1">
-                <a:shade val="50000"/>
-              </a:schemeClr>
-            </a:lnRef>
-            <a:fillRef idx="1">
-              <a:schemeClr val="accent1"/>
-            </a:fillRef>
-            <a:effectRef idx="0">
-              <a:schemeClr val="accent1"/>
-            </a:effectRef>
-            <a:fontRef idx="minor">
-              <a:schemeClr val="lt1"/>
-            </a:fontRef>
-          </p:style>
-          <p:txBody>
-            <a:bodyPr rtlCol="0" anchor="ctr"/>
-            <a:lstStyle/>
-            <a:p>
-              <a:pPr algn="ctr"/>
-              <a:endParaRPr lang="en-US"/>
-            </a:p>
-          </p:txBody>
-        </p:sp>
-        <p:sp>
-          <p:nvSpPr>
-            <p:cNvPr id="13" name="Rectangle 12">
-              <a:extLst>
-                <a:ext uri="{FF2B5EF4-FFF2-40B4-BE49-F238E27FC236}">
-                  <a16:creationId xmlns:a16="http://schemas.microsoft.com/office/drawing/2014/main" id="{467C4786-4059-3030-109A-7219ADFD8889}"/>
-                </a:ext>
-                <a:ext uri="{C183D7F6-B498-43B3-948B-1728B52AA6E4}">
-                  <adec:decorative xmlns:adec="http://schemas.microsoft.com/office/drawing/2017/decorative" val="1"/>
-                </a:ext>
-              </a:extLst>
-            </p:cNvPr>
-            <p:cNvSpPr/>
-            <p:nvPr>
-              <p:extLst>
-                <p:ext uri="{386F3935-93C4-4BCD-93E2-E3B085C9AB24}">
-                  <p16:designElem xmlns:p16="http://schemas.microsoft.com/office/powerpoint/2015/main" val="1"/>
-                </p:ext>
-              </p:extLst>
-            </p:nvPr>
-          </p:nvSpPr>
-          <p:spPr>
-            <a:xfrm>
-              <a:off x="5490650" y="308034"/>
-              <a:ext cx="566743" cy="3428999"/>
-            </a:xfrm>
-            <a:prstGeom prst="rect">
-              <a:avLst/>
-            </a:prstGeom>
-            <a:grpFill/>
-            <a:ln>
-              <a:noFill/>
-            </a:ln>
-          </p:spPr>
-          <p:style>
-            <a:lnRef idx="2">
-              <a:schemeClr val="accent1">
-                <a:shade val="50000"/>
-              </a:schemeClr>
-            </a:lnRef>
-            <a:fillRef idx="1">
-              <a:schemeClr val="accent1"/>
-            </a:fillRef>
-            <a:effectRef idx="0">
-              <a:schemeClr val="accent1"/>
-            </a:effectRef>
-            <a:fontRef idx="minor">
-              <a:schemeClr val="lt1"/>
-            </a:fontRef>
-          </p:style>
-          <p:txBody>
-            <a:bodyPr rtlCol="0" anchor="ctr"/>
-            <a:lstStyle/>
-            <a:p>
-              <a:pPr algn="ctr"/>
-              <a:endParaRPr lang="en-US"/>
-            </a:p>
-          </p:txBody>
-        </p:sp>
-      </p:grpSp>
-      <p:sp>
-        <p:nvSpPr>
-          <p:cNvPr id="15" name="Rectangle 14">
-            <a:extLst>
-              <a:ext uri="{FF2B5EF4-FFF2-40B4-BE49-F238E27FC236}">
-                <a16:creationId xmlns:a16="http://schemas.microsoft.com/office/drawing/2014/main" id="{D0DD96FB-5E9B-7D47-E856-37EEBDD83EF7}"/>
-              </a:ext>
-              <a:ext uri="{C183D7F6-B498-43B3-948B-1728B52AA6E4}">
-                <adec:decorative xmlns:adec="http://schemas.microsoft.com/office/drawing/2017/decorative" val="1"/>
-              </a:ext>
-            </a:extLst>
-          </p:cNvPr>
-          <p:cNvSpPr>
-            <a:spLocks noGrp="1" noRot="1" noChangeAspect="1" noMove="1" noResize="1" noEditPoints="1" noAdjustHandles="1" noChangeArrowheads="1" noChangeShapeType="1" noTextEdit="1"/>
-          </p:cNvSpPr>
-          <p:nvPr>
-            <p:extLst>
-              <p:ext uri="{386F3935-93C4-4BCD-93E2-E3B085C9AB24}">
-                <p16:designElem xmlns:p16="http://schemas.microsoft.com/office/powerpoint/2015/main" val="1"/>
-              </p:ext>
-            </p:extLst>
-          </p:nvPr>
-        </p:nvSpPr>
-        <p:spPr>
-          <a:xfrm>
-            <a:off x="640079" y="613954"/>
-            <a:ext cx="10907487" cy="1894116"/>
-          </a:xfrm>
-          <a:prstGeom prst="rect">
-            <a:avLst/>
-          </a:prstGeom>
-          <a:solidFill>
-            <a:schemeClr val="bg1"/>
-          </a:solidFill>
-          <a:ln>
-            <a:noFill/>
-          </a:ln>
-          <a:effectLst>
-            <a:outerShdw blurRad="139700" dist="127000" dir="5400000" algn="t" rotWithShape="0">
-              <a:prstClr val="black">
-                <a:alpha val="15000"/>
-              </a:prstClr>
-            </a:outerShdw>
-          </a:effectLst>
-        </p:spPr>
-        <p:style>
-          <a:lnRef idx="2">
-            <a:schemeClr val="accent1">
-              <a:shade val="50000"/>
-            </a:schemeClr>
-          </a:lnRef>
-          <a:fillRef idx="1">
-            <a:schemeClr val="accent1"/>
-          </a:fillRef>
-          <a:effectRef idx="0">
-            <a:schemeClr val="accent1"/>
-          </a:effectRef>
-          <a:fontRef idx="minor">
-            <a:schemeClr val="lt1"/>
-          </a:fontRef>
-        </p:style>
-        <p:txBody>
-          <a:bodyPr rtlCol="0" anchor="ctr"/>
-          <a:lstStyle/>
-          <a:p>
-            <a:pPr algn="ctr"/>
-            <a:endParaRPr lang="en-US"/>
-          </a:p>
-        </p:txBody>
-      </p:sp>
-      <p:sp>
-        <p:nvSpPr>
-          <p:cNvPr id="2" name="Title 1">
-            <a:extLst>
-              <a:ext uri="{FF2B5EF4-FFF2-40B4-BE49-F238E27FC236}">
-                <a16:creationId xmlns:a16="http://schemas.microsoft.com/office/drawing/2014/main" id="{263FDBDF-138B-31E8-D853-79A35F3F7E0B}"/>
-              </a:ext>
-            </a:extLst>
-          </p:cNvPr>
-          <p:cNvSpPr>
-            <a:spLocks noGrp="1"/>
-          </p:cNvSpPr>
-          <p:nvPr>
-            <p:ph type="title"/>
-          </p:nvPr>
-        </p:nvSpPr>
-        <p:spPr>
-          <a:xfrm>
-            <a:off x="1043631" y="809898"/>
-            <a:ext cx="9942716" cy="1554480"/>
-          </a:xfrm>
-        </p:spPr>
-        <p:txBody>
-          <a:bodyPr anchor="ctr">
-            <a:normAutofit/>
-          </a:bodyPr>
-          <a:lstStyle/>
-          <a:p>
-            <a:r>
-              <a:rPr lang="en-US" sz="4800" dirty="0"/>
-              <a:t>Weighted Mean</a:t>
-            </a:r>
-            <a:endParaRPr lang="en-GB" sz="4800" dirty="0"/>
-          </a:p>
-        </p:txBody>
-      </p:sp>
-      <mc:AlternateContent xmlns:mc="http://schemas.openxmlformats.org/markup-compatibility/2006">
-        <mc:Choice xmlns:a14="http://schemas.microsoft.com/office/drawing/2010/main" Requires="a14">
-          <p:sp>
-            <p:nvSpPr>
-              <p:cNvPr id="3" name="Content Placeholder 2">
-                <a:extLst>
-                  <a:ext uri="{FF2B5EF4-FFF2-40B4-BE49-F238E27FC236}">
-                    <a16:creationId xmlns:a16="http://schemas.microsoft.com/office/drawing/2014/main" id="{9A2994AC-FE77-AB15-01F8-B5903ED1EA66}"/>
-                  </a:ext>
-                </a:extLst>
-              </p:cNvPr>
-              <p:cNvSpPr>
-                <a:spLocks noGrp="1"/>
-              </p:cNvSpPr>
-              <p:nvPr>
-                <p:ph idx="1"/>
-              </p:nvPr>
-            </p:nvSpPr>
-            <p:spPr>
-              <a:xfrm>
-                <a:off x="1045028" y="3017522"/>
-                <a:ext cx="9941319" cy="3124658"/>
-              </a:xfrm>
-            </p:spPr>
-            <p:txBody>
-              <a:bodyPr anchor="ctr">
-                <a:normAutofit/>
-              </a:bodyPr>
-              <a:lstStyle/>
-              <a:p>
-                <a:pPr marL="0" indent="0" algn="just">
-                  <a:buNone/>
-                </a:pPr>
-                <a:r>
-                  <a:rPr lang="en-US" sz="2200" dirty="0"/>
-                  <a:t>Weighted mean is calculated by multiplying each data values by a weight and dividing their sum by the sum of weights.</a:t>
-                </a:r>
-              </a:p>
-              <a:p>
-                <a:endParaRPr lang="en-US" sz="2200" dirty="0"/>
-              </a:p>
-              <a:p>
-                <a:pPr marL="0" indent="0">
-                  <a:buNone/>
-                </a:pPr>
-                <a14:m>
-                  <m:oMathPara xmlns:m="http://schemas.openxmlformats.org/officeDocument/2006/math">
-                    <m:oMathParaPr>
-                      <m:jc m:val="centerGroup"/>
-                    </m:oMathParaPr>
-                    <m:oMath xmlns:m="http://schemas.openxmlformats.org/officeDocument/2006/math">
-                      <m:r>
-                        <a:rPr lang="en-US" sz="2200" i="1">
-                          <a:latin typeface="Cambria Math" panose="02040503050406030204" pitchFamily="18" charset="0"/>
-                          <a:ea typeface="Cambria Math" panose="02040503050406030204" pitchFamily="18" charset="0"/>
-                        </a:rPr>
-                        <m:t>𝑥</m:t>
-                      </m:r>
-                      <m:r>
-                        <a:rPr lang="en-US" sz="2200" b="0" i="1" baseline="-25000" smtClean="0">
-                          <a:latin typeface="Cambria Math" panose="02040503050406030204" pitchFamily="18" charset="0"/>
-                          <a:ea typeface="Cambria Math" panose="02040503050406030204" pitchFamily="18" charset="0"/>
-                        </a:rPr>
-                        <m:t>𝑤</m:t>
-                      </m:r>
-                      <m:r>
-                        <a:rPr lang="en-US" sz="2200" b="0" i="1">
-                          <a:latin typeface="Cambria Math" panose="02040503050406030204" pitchFamily="18" charset="0"/>
-                          <a:ea typeface="Cambria Math" panose="02040503050406030204" pitchFamily="18" charset="0"/>
-                        </a:rPr>
-                        <m:t>=</m:t>
-                      </m:r>
-                      <m:f>
-                        <m:fPr>
-                          <m:ctrlPr>
-                            <a:rPr lang="en-US" sz="2200" b="0" i="1" smtClean="0">
-                              <a:latin typeface="Cambria Math" panose="02040503050406030204" pitchFamily="18" charset="0"/>
-                              <a:ea typeface="Cambria Math" panose="02040503050406030204" pitchFamily="18" charset="0"/>
-                            </a:rPr>
-                          </m:ctrlPr>
-                        </m:fPr>
-                        <m:num>
-                          <m:nary>
-                            <m:naryPr>
-                              <m:chr m:val="∑"/>
-                              <m:ctrlPr>
-                                <a:rPr lang="en-US" sz="2200" i="1">
-                                  <a:latin typeface="Cambria Math" panose="02040503050406030204" pitchFamily="18" charset="0"/>
-                                  <a:ea typeface="Cambria Math" panose="02040503050406030204" pitchFamily="18" charset="0"/>
-                                </a:rPr>
-                              </m:ctrlPr>
-                            </m:naryPr>
-                            <m:sub>
-                              <m:r>
-                                <m:rPr>
-                                  <m:brk m:alnAt="23"/>
-                                </m:rPr>
-                                <a:rPr lang="en-US" sz="2200" i="1">
-                                  <a:latin typeface="Cambria Math" panose="02040503050406030204" pitchFamily="18" charset="0"/>
-                                  <a:ea typeface="Cambria Math" panose="02040503050406030204" pitchFamily="18" charset="0"/>
-                                </a:rPr>
-                                <m:t>𝑖</m:t>
-                              </m:r>
-                              <m:r>
-                                <a:rPr lang="en-US" sz="2200" i="1">
-                                  <a:latin typeface="Cambria Math" panose="02040503050406030204" pitchFamily="18" charset="0"/>
-                                  <a:ea typeface="Cambria Math" panose="02040503050406030204" pitchFamily="18" charset="0"/>
-                                </a:rPr>
-                                <m:t>=1</m:t>
-                              </m:r>
-                            </m:sub>
-                            <m:sup>
-                              <m:r>
-                                <a:rPr lang="en-US" sz="2200" i="1">
-                                  <a:latin typeface="Cambria Math" panose="02040503050406030204" pitchFamily="18" charset="0"/>
-                                  <a:ea typeface="Cambria Math" panose="02040503050406030204" pitchFamily="18" charset="0"/>
-                                </a:rPr>
-                                <m:t>𝑛</m:t>
-                              </m:r>
-                            </m:sup>
-                            <m:e>
-                              <m:r>
-                                <a:rPr lang="en-US" sz="2200" b="0" i="1" smtClean="0">
-                                  <a:latin typeface="Cambria Math" panose="02040503050406030204" pitchFamily="18" charset="0"/>
-                                  <a:ea typeface="Cambria Math" panose="02040503050406030204" pitchFamily="18" charset="0"/>
-                                </a:rPr>
-                                <m:t>𝑤</m:t>
-                              </m:r>
-                              <m:r>
-                                <a:rPr lang="en-US" sz="2200" i="1" baseline="-25000">
-                                  <a:latin typeface="Cambria Math" panose="02040503050406030204" pitchFamily="18" charset="0"/>
-                                  <a:ea typeface="Cambria Math" panose="02040503050406030204" pitchFamily="18" charset="0"/>
-                                </a:rPr>
-                                <m:t>𝑖</m:t>
-                              </m:r>
-                              <m:r>
-                                <a:rPr lang="en-US" sz="2200" i="1">
-                                  <a:latin typeface="Cambria Math" panose="02040503050406030204" pitchFamily="18" charset="0"/>
-                                  <a:ea typeface="Cambria Math" panose="02040503050406030204" pitchFamily="18" charset="0"/>
-                                </a:rPr>
-                                <m:t>𝑥</m:t>
-                              </m:r>
-                              <m:r>
-                                <a:rPr lang="en-US" sz="2200" i="1" baseline="-25000">
-                                  <a:latin typeface="Cambria Math" panose="02040503050406030204" pitchFamily="18" charset="0"/>
-                                  <a:ea typeface="Cambria Math" panose="02040503050406030204" pitchFamily="18" charset="0"/>
-                                </a:rPr>
-                                <m:t>𝑖</m:t>
-                              </m:r>
-                            </m:e>
-                          </m:nary>
-                          <m:r>
-                            <m:rPr>
-                              <m:nor/>
-                            </m:rPr>
-                            <a:rPr lang="pt-BR" sz="2200" dirty="0"/>
-                            <m:t> </m:t>
-                          </m:r>
-                        </m:num>
-                        <m:den>
-                          <m:nary>
-                            <m:naryPr>
-                              <m:chr m:val="∑"/>
-                              <m:ctrlPr>
-                                <a:rPr lang="en-US" sz="2200" i="1">
-                                  <a:latin typeface="Cambria Math" panose="02040503050406030204" pitchFamily="18" charset="0"/>
-                                  <a:ea typeface="Cambria Math" panose="02040503050406030204" pitchFamily="18" charset="0"/>
-                                </a:rPr>
-                              </m:ctrlPr>
-                            </m:naryPr>
-                            <m:sub>
-                              <m:r>
-                                <m:rPr>
-                                  <m:brk m:alnAt="23"/>
-                                </m:rPr>
-                                <a:rPr lang="en-US" sz="2200" i="1">
-                                  <a:latin typeface="Cambria Math" panose="02040503050406030204" pitchFamily="18" charset="0"/>
-                                  <a:ea typeface="Cambria Math" panose="02040503050406030204" pitchFamily="18" charset="0"/>
-                                </a:rPr>
-                                <m:t>𝑖</m:t>
-                              </m:r>
-                            </m:sub>
-                            <m:sup>
-                              <m:r>
-                                <a:rPr lang="en-US" sz="2200" i="1">
-                                  <a:latin typeface="Cambria Math" panose="02040503050406030204" pitchFamily="18" charset="0"/>
-                                  <a:ea typeface="Cambria Math" panose="02040503050406030204" pitchFamily="18" charset="0"/>
-                                </a:rPr>
-                                <m:t>𝑛</m:t>
-                              </m:r>
-                            </m:sup>
-                            <m:e>
-                              <m:r>
-                                <a:rPr lang="en-US" sz="2200" b="0" i="1" smtClean="0">
-                                  <a:latin typeface="Cambria Math" panose="02040503050406030204" pitchFamily="18" charset="0"/>
-                                  <a:ea typeface="Cambria Math" panose="02040503050406030204" pitchFamily="18" charset="0"/>
-                                </a:rPr>
-                                <m:t>𝑤</m:t>
-                              </m:r>
-                              <m:r>
-                                <a:rPr lang="en-US" sz="2200" i="1" baseline="-25000">
-                                  <a:latin typeface="Cambria Math" panose="02040503050406030204" pitchFamily="18" charset="0"/>
-                                  <a:ea typeface="Cambria Math" panose="02040503050406030204" pitchFamily="18" charset="0"/>
-                                </a:rPr>
-                                <m:t>𝑖</m:t>
-                              </m:r>
-                            </m:e>
-                          </m:nary>
-                          <m:r>
-                            <m:rPr>
-                              <m:nor/>
-                            </m:rPr>
-                            <a:rPr lang="pt-BR" sz="2200" dirty="0"/>
-                            <m:t> </m:t>
-                          </m:r>
-                        </m:den>
-                      </m:f>
-                    </m:oMath>
-                  </m:oMathPara>
-                </a14:m>
-                <a:br>
-                  <a:rPr lang="pt-BR" sz="2200" dirty="0"/>
-                </a:br>
-                <a:br>
-                  <a:rPr lang="pt-BR" sz="2200" dirty="0"/>
-                </a:br>
-                <a:endParaRPr lang="en-GB" sz="2200" dirty="0"/>
-              </a:p>
-            </p:txBody>
-          </p:sp>
-        </mc:Choice>
-        <mc:Fallback>
-          <p:sp>
-            <p:nvSpPr>
-              <p:cNvPr id="3" name="Content Placeholder 2">
-                <a:extLst>
-                  <a:ext uri="{FF2B5EF4-FFF2-40B4-BE49-F238E27FC236}">
-                    <a16:creationId xmlns:a16="http://schemas.microsoft.com/office/drawing/2014/main" id="{9A2994AC-FE77-AB15-01F8-B5903ED1EA66}"/>
-                  </a:ext>
-                </a:extLst>
-              </p:cNvPr>
-              <p:cNvSpPr>
-                <a:spLocks noGrp="1" noRot="1" noChangeAspect="1" noMove="1" noResize="1" noEditPoints="1" noAdjustHandles="1" noChangeArrowheads="1" noChangeShapeType="1" noTextEdit="1"/>
-              </p:cNvSpPr>
-              <p:nvPr>
-                <p:ph idx="1"/>
-              </p:nvPr>
-            </p:nvSpPr>
-            <p:spPr>
-              <a:xfrm>
-                <a:off x="1045028" y="3017522"/>
-                <a:ext cx="9941319" cy="3124658"/>
-              </a:xfrm>
-              <a:blipFill>
-                <a:blip r:embed="rId2"/>
-                <a:stretch>
-                  <a:fillRect l="-797" r="-797"/>
-                </a:stretch>
-              </a:blipFill>
-            </p:spPr>
-            <p:txBody>
-              <a:bodyPr/>
-              <a:lstStyle/>
-              <a:p>
-                <a:r>
-                  <a:rPr lang="en-GB">
-                    <a:noFill/>
-                  </a:rPr>
-                  <a:t> </a:t>
-                </a:r>
-              </a:p>
-            </p:txBody>
-          </p:sp>
-        </mc:Fallback>
-      </mc:AlternateContent>
-      <p:cxnSp>
-        <p:nvCxnSpPr>
-          <p:cNvPr id="17" name="Straight Connector 16">
-            <a:extLst>
-              <a:ext uri="{FF2B5EF4-FFF2-40B4-BE49-F238E27FC236}">
-                <a16:creationId xmlns:a16="http://schemas.microsoft.com/office/drawing/2014/main" id="{3F71B0E8-E374-720D-BC00-F5A28A7C4BEE}"/>
-              </a:ext>
-              <a:ext uri="{C183D7F6-B498-43B3-948B-1728B52AA6E4}">
-                <adec:decorative xmlns:adec="http://schemas.microsoft.com/office/drawing/2017/decorative" val="1"/>
-              </a:ext>
-            </a:extLst>
-          </p:cNvPr>
-          <p:cNvCxnSpPr>
-            <a:cxnSpLocks noGrp="1" noRot="1" noChangeAspect="1" noMove="1" noResize="1" noEditPoints="1" noAdjustHandles="1" noChangeArrowheads="1" noChangeShapeType="1"/>
-          </p:cNvCxnSpPr>
-          <p:nvPr>
-            <p:extLst>
-              <p:ext uri="{386F3935-93C4-4BCD-93E2-E3B085C9AB24}">
-                <p16:designElem xmlns:p16="http://schemas.microsoft.com/office/powerpoint/2015/main" val="1"/>
-              </p:ext>
-            </p:extLst>
-          </p:nvPr>
-        </p:nvCxnSpPr>
-        <p:spPr>
-          <a:xfrm flipH="1">
-            <a:off x="838200" y="6485313"/>
-            <a:ext cx="10515600" cy="0"/>
-          </a:xfrm>
-          <a:prstGeom prst="line">
-            <a:avLst/>
-          </a:prstGeom>
-          <a:ln w="57150">
-            <a:solidFill>
-              <a:schemeClr val="accent4"/>
-            </a:solidFill>
-          </a:ln>
-        </p:spPr>
-        <p:style>
-          <a:lnRef idx="1">
-            <a:schemeClr val="accent1"/>
-          </a:lnRef>
-          <a:fillRef idx="0">
-            <a:schemeClr val="accent1"/>
-          </a:fillRef>
-          <a:effectRef idx="0">
-            <a:schemeClr val="accent1"/>
-          </a:effectRef>
-          <a:fontRef idx="minor">
-            <a:schemeClr val="tx1"/>
-          </a:fontRef>
-        </p:style>
-      </p:cxnSp>
-    </p:spTree>
-    <p:extLst>
-      <p:ext uri="{BB962C8B-B14F-4D97-AF65-F5344CB8AC3E}">
-        <p14:creationId xmlns:p14="http://schemas.microsoft.com/office/powerpoint/2010/main" val="3602796130"/>
-      </p:ext>
-    </p:extLst>
-  </p:cSld>
-  <p:clrMapOvr>
-    <a:masterClrMapping/>
-  </p:clrMapOvr>
-</p:sld>
-</file>
-
-<file path=ppt/slides/slide5.xml><?xml version="1.0" encoding="utf-8"?>
-<p:sld xmlns:a="http://schemas.openxmlformats.org/drawingml/2006/main" xmlns:r="http://schemas.openxmlformats.org/officeDocument/2006/relationships" xmlns:p="http://schemas.openxmlformats.org/presentationml/2006/main">
-  <p:cSld>
-    <p:bg>
-      <p:bgPr>
-        <a:solidFill>
-          <a:schemeClr val="bg1"/>
-        </a:solidFill>
-        <a:effectLst/>
-      </p:bgPr>
-    </p:bg>
-    <p:spTree>
-      <p:nvGrpSpPr>
-        <p:cNvPr id="1" name="">
-          <a:extLst>
-            <a:ext uri="{FF2B5EF4-FFF2-40B4-BE49-F238E27FC236}">
               <a16:creationId xmlns:a16="http://schemas.microsoft.com/office/drawing/2014/main" id="{643825DE-C2B7-E869-F1C1-70957F9A591C}"/>
             </a:ext>
           </a:extLst>
@@ -11132,7 +10382,7 @@
 </p:sld>
 </file>
 
-<file path=ppt/slides/slide6.xml><?xml version="1.0" encoding="utf-8"?>
+<file path=ppt/slides/slide5.xml><?xml version="1.0" encoding="utf-8"?>
 <p:sld xmlns:a="http://schemas.openxmlformats.org/drawingml/2006/main" xmlns:r="http://schemas.openxmlformats.org/officeDocument/2006/relationships" xmlns:p="http://schemas.openxmlformats.org/presentationml/2006/main">
   <p:cSld>
     <p:bg>
@@ -11854,7 +11104,7 @@
 </p:sld>
 </file>
 
-<file path=ppt/slides/slide7.xml><?xml version="1.0" encoding="utf-8"?>
+<file path=ppt/slides/slide6.xml><?xml version="1.0" encoding="utf-8"?>
 <p:sld xmlns:a="http://schemas.openxmlformats.org/drawingml/2006/main" xmlns:r="http://schemas.openxmlformats.org/officeDocument/2006/relationships" xmlns:p="http://schemas.openxmlformats.org/presentationml/2006/main">
   <p:cSld>
     <p:spTree>
@@ -11982,7 +11232,7 @@
 </p:sld>
 </file>
 
-<file path=ppt/slides/slide8.xml><?xml version="1.0" encoding="utf-8"?>
+<file path=ppt/slides/slide7.xml><?xml version="1.0" encoding="utf-8"?>
 <p:sld xmlns:a="http://schemas.openxmlformats.org/drawingml/2006/main" xmlns:r="http://schemas.openxmlformats.org/officeDocument/2006/relationships" xmlns:p="http://schemas.openxmlformats.org/presentationml/2006/main">
   <p:cSld>
     <p:bg>

</xml_diff>